<commit_message>
rev4 charts: stacked OMDA segment on gap chart; H1 availability bar highlighted; H2 gap callout; H4 data labels + per-area gap strip
Co-Authored-By: Claude Fable 5 <noreply@anthropic.com>
</commit_message>
<xml_diff>
--- a/files/Danone_Presentation_rev4.pptx
+++ b/files/Danone_Presentation_rev4.pptx
@@ -140,7 +140,7 @@
       <c:layout/>
       <c:barChart>
         <c:barDir val="col"/>
-        <c:grouping val="clustered"/>
+        <c:grouping val="stacked"/>
         <c:varyColors val="0"/>
         <c:ser>
           <c:idx val="0"/>
@@ -151,7 +151,7 @@
               <c:strCache>
                 <c:ptCount val="1"/>
                 <c:pt idx="0">
-                  <c:v>Retail outlets reached</c:v>
+                  <c:v>Juhayna network</c:v>
                 </c:pt>
               </c:strCache>
             </c:strRef>
@@ -172,7 +172,7 @@
                 <a:pPr>
                   <a:defRPr b="0" i="0" strike="noStrike" sz="1100" u="none">
                     <a:solidFill>
-                      <a:srgbClr val="1A2A38"/>
+                      <a:srgbClr val="FFFFFF"/>
                     </a:solidFill>
                     <a:latin typeface="Arial"/>
                   </a:defRPr>
@@ -187,28 +187,6 @@
             <c:showBubbleSize val="0"/>
             <c:showLeaderLines val="0"/>
           </c:dLbls>
-          <c:dPt>
-            <c:idx val="0"/>
-            <c:invertIfNegative val="0"/>
-            <c:bubble3D val="0"/>
-            <c:spPr>
-              <a:solidFill>
-                <a:srgbClr val="E0922F"/>
-              </a:solidFill>
-              <a:effectLst/>
-            </c:spPr>
-          </c:dPt>
-          <c:dPt>
-            <c:idx val="1"/>
-            <c:invertIfNegative val="0"/>
-            <c:bubble3D val="0"/>
-            <c:spPr>
-              <a:solidFill>
-                <a:srgbClr val="1C6CAB"/>
-              </a:solidFill>
-              <a:effectLst/>
-            </c:spPr>
-          </c:dPt>
           <c:cat>
             <c:multiLvlStrRef>
               <c:f>Sheet1!$A$2:$A$3</c:f>
@@ -235,7 +213,161 @@
                   <c:v>136000</c:v>
                 </c:pt>
                 <c:pt idx="1">
+                  <c:v/>
+                </c:pt>
+              </c:numCache>
+            </c:numRef>
+          </c:val>
+        </c:ser>
+        <c:ser>
+          <c:idx val="1"/>
+          <c:order val="1"/>
+          <c:tx>
+            <c:strRef>
+              <c:f>Sheet1!$C$1</c:f>
+              <c:strCache>
+                <c:ptCount val="1"/>
+                <c:pt idx="0">
+                  <c:v>Danone core network</c:v>
+                </c:pt>
+              </c:strCache>
+            </c:strRef>
+          </c:tx>
+          <c:spPr>
+            <a:solidFill>
+              <a:srgbClr val="1C6CAB"/>
+            </a:solidFill>
+            <a:effectLst/>
+          </c:spPr>
+          <c:invertIfNegative val="0"/>
+          <c:dLbls>
+            <c:numFmt formatCode="#,##0" sourceLinked="0"/>
+            <c:txPr>
+              <a:bodyPr/>
+              <a:lstStyle/>
+              <a:p>
+                <a:pPr>
+                  <a:defRPr b="0" i="0" strike="noStrike" sz="1100" u="none">
+                    <a:solidFill>
+                      <a:srgbClr val="FFFFFF"/>
+                    </a:solidFill>
+                    <a:latin typeface="Arial"/>
+                  </a:defRPr>
+                </a:pPr>
+              </a:p>
+            </c:txPr>
+            <c:showLegendKey val="0"/>
+            <c:showVal val="1"/>
+            <c:showCatName val="0"/>
+            <c:showSerName val="0"/>
+            <c:showPercent val="0"/>
+            <c:showBubbleSize val="0"/>
+            <c:showLeaderLines val="0"/>
+          </c:dLbls>
+          <c:cat>
+            <c:multiLvlStrRef>
+              <c:f>Sheet1!$A$2:$A$3</c:f>
+              <c:multiLvlStrCache>
+                <c:ptCount val="2"/>
+                <c:lvl>
+                  <c:pt idx="0">
+                    <c:v>Juhayna</c:v>
+                  </c:pt>
+                  <c:pt idx="1">
+                    <c:v>Danone</c:v>
+                  </c:pt>
+                </c:lvl>
+              </c:multiLvlStrCache>
+            </c:multiLvlStrRef>
+          </c:cat>
+          <c:val>
+            <c:numRef>
+              <c:f>Sheet1!$C$2:$C$3</c:f>
+              <c:numCache>
+                <c:formatCode>General</c:formatCode>
+                <c:ptCount val="2"/>
+                <c:pt idx="0">
+                  <c:v/>
+                </c:pt>
+                <c:pt idx="1">
                   <c:v>100000</c:v>
+                </c:pt>
+              </c:numCache>
+            </c:numRef>
+          </c:val>
+        </c:ser>
+        <c:ser>
+          <c:idx val="2"/>
+          <c:order val="2"/>
+          <c:tx>
+            <c:strRef>
+              <c:f>Sheet1!$D$1</c:f>
+              <c:strCache>
+                <c:ptCount val="1"/>
+                <c:pt idx="0">
+                  <c:v>OMDA rural project (light-touch)</c:v>
+                </c:pt>
+              </c:strCache>
+            </c:strRef>
+          </c:tx>
+          <c:spPr>
+            <a:solidFill>
+              <a:srgbClr val="9CC3E4"/>
+            </a:solidFill>
+            <a:effectLst/>
+          </c:spPr>
+          <c:invertIfNegative val="0"/>
+          <c:dLbls>
+            <c:numFmt formatCode="#,##0" sourceLinked="0"/>
+            <c:txPr>
+              <a:bodyPr/>
+              <a:lstStyle/>
+              <a:p>
+                <a:pPr>
+                  <a:defRPr b="0" i="0" strike="noStrike" sz="1100" u="none">
+                    <a:solidFill>
+                      <a:srgbClr val="FFFFFF"/>
+                    </a:solidFill>
+                    <a:latin typeface="Arial"/>
+                  </a:defRPr>
+                </a:pPr>
+              </a:p>
+            </c:txPr>
+            <c:showLegendKey val="0"/>
+            <c:showVal val="1"/>
+            <c:showCatName val="0"/>
+            <c:showSerName val="0"/>
+            <c:showPercent val="0"/>
+            <c:showBubbleSize val="0"/>
+            <c:showLeaderLines val="0"/>
+          </c:dLbls>
+          <c:cat>
+            <c:multiLvlStrRef>
+              <c:f>Sheet1!$A$2:$A$3</c:f>
+              <c:multiLvlStrCache>
+                <c:ptCount val="2"/>
+                <c:lvl>
+                  <c:pt idx="0">
+                    <c:v>Juhayna</c:v>
+                  </c:pt>
+                  <c:pt idx="1">
+                    <c:v>Danone</c:v>
+                  </c:pt>
+                </c:lvl>
+              </c:multiLvlStrCache>
+            </c:multiLvlStrRef>
+          </c:cat>
+          <c:val>
+            <c:numRef>
+              <c:f>Sheet1!$D$2:$D$3</c:f>
+              <c:numCache>
+                <c:formatCode>General</c:formatCode>
+                <c:ptCount val="2"/>
+                <c:pt idx="0">
+                  <c:v/>
+                </c:pt>
+                <c:pt idx="1">
+                  <c:v>50000</c:v>
                 </c:pt>
               </c:numCache>
             </c:numRef>
@@ -250,7 +382,7 @@
               <a:pPr>
                 <a:defRPr b="0" i="0" strike="noStrike" sz="1100" u="none">
                   <a:solidFill>
-                    <a:srgbClr val="1A2A38"/>
+                    <a:srgbClr val="FFFFFF"/>
                   </a:solidFill>
                   <a:latin typeface="Arial"/>
                 </a:defRPr>
@@ -266,7 +398,7 @@
           <c:showLeaderLines val="0"/>
         </c:dLbls>
         <c:gapWidth val="60"/>
-        <c:overlap val="0"/>
+        <c:overlap val="100"/>
         <c:axId val="2094734554"/>
         <c:axId val="2094734552"/>
         <c:axId val="2094734556"/>
@@ -370,6 +502,24 @@
         <a:effectLst/>
       </c:spPr>
     </c:plotArea>
+    <c:legend>
+      <c:legendPos val="b"/>
+      <c:overlay val="0"/>
+      <c:txPr>
+        <a:bodyPr/>
+        <a:lstStyle/>
+        <a:p>
+          <a:pPr>
+            <a:defRPr sz="1000">
+              <a:solidFill>
+                <a:srgbClr val="6B7C8C"/>
+              </a:solidFill>
+            </a:defRPr>
+          </a:pPr>
+          <a:endParaRPr lang="en-US"/>
+        </a:p>
+      </c:txPr>
+    </c:legend>
     <c:plotVisOnly val="1"/>
     <c:dispBlanksAs val="span"/>
   </c:chart>
@@ -445,6 +595,72 @@
             <c:showBubbleSize val="0"/>
             <c:showLeaderLines val="0"/>
           </c:dLbls>
+          <c:dPt>
+            <c:idx val="0"/>
+            <c:invertIfNegative val="0"/>
+            <c:bubble3D val="0"/>
+            <c:spPr>
+              <a:solidFill>
+                <a:srgbClr val="1C6CAB"/>
+              </a:solidFill>
+              <a:effectLst/>
+            </c:spPr>
+          </c:dPt>
+          <c:dPt>
+            <c:idx val="1"/>
+            <c:invertIfNegative val="0"/>
+            <c:bubble3D val="0"/>
+            <c:spPr>
+              <a:solidFill>
+                <a:srgbClr val="1C6CAB"/>
+              </a:solidFill>
+              <a:effectLst/>
+            </c:spPr>
+          </c:dPt>
+          <c:dPt>
+            <c:idx val="2"/>
+            <c:invertIfNegative val="0"/>
+            <c:bubble3D val="0"/>
+            <c:spPr>
+              <a:solidFill>
+                <a:srgbClr val="1C6CAB"/>
+              </a:solidFill>
+              <a:effectLst/>
+            </c:spPr>
+          </c:dPt>
+          <c:dPt>
+            <c:idx val="3"/>
+            <c:invertIfNegative val="0"/>
+            <c:bubble3D val="0"/>
+            <c:spPr>
+              <a:solidFill>
+                <a:srgbClr val="1C6CAB"/>
+              </a:solidFill>
+              <a:effectLst/>
+            </c:spPr>
+          </c:dPt>
+          <c:dPt>
+            <c:idx val="4"/>
+            <c:invertIfNegative val="0"/>
+            <c:bubble3D val="0"/>
+            <c:spPr>
+              <a:solidFill>
+                <a:srgbClr val="1C6CAB"/>
+              </a:solidFill>
+              <a:effectLst/>
+            </c:spPr>
+          </c:dPt>
+          <c:dPt>
+            <c:idx val="5"/>
+            <c:invertIfNegative val="0"/>
+            <c:bubble3D val="0"/>
+            <c:spPr>
+              <a:solidFill>
+                <a:srgbClr val="E1604D"/>
+              </a:solidFill>
+              <a:effectLst/>
+            </c:spPr>
+          </c:dPt>
           <c:cat>
             <c:multiLvlStrRef>
               <c:f>Sheet1!$A$2:$A$7</c:f>
@@ -961,15 +1177,15 @@
           </c:spPr>
           <c:invertIfNegative val="0"/>
           <c:dLbls>
-            <c:numFmt formatCode="#,##0" sourceLinked="0"/>
+            <c:numFmt formatCode="0.00" sourceLinked="0"/>
             <c:txPr>
               <a:bodyPr/>
               <a:lstStyle/>
               <a:p>
                 <a:pPr>
-                  <a:defRPr b="0" i="0" strike="noStrike" sz="1200" u="none">
+                  <a:defRPr b="0" i="0" strike="noStrike" sz="900" u="none">
                     <a:solidFill>
-                      <a:srgbClr val="000000"/>
+                      <a:srgbClr val="1A2A38"/>
                     </a:solidFill>
                     <a:latin typeface="Arial"/>
                   </a:defRPr>
@@ -977,7 +1193,7 @@
               </a:p>
             </c:txPr>
             <c:showLegendKey val="0"/>
-            <c:showVal val="0"/>
+            <c:showVal val="1"/>
             <c:showCatName val="0"/>
             <c:showSerName val="0"/>
             <c:showPercent val="0"/>
@@ -1044,15 +1260,15 @@
           </c:spPr>
           <c:invertIfNegative val="0"/>
           <c:dLbls>
-            <c:numFmt formatCode="#,##0" sourceLinked="0"/>
+            <c:numFmt formatCode="0.00" sourceLinked="0"/>
             <c:txPr>
               <a:bodyPr/>
               <a:lstStyle/>
               <a:p>
                 <a:pPr>
-                  <a:defRPr b="0" i="0" strike="noStrike" sz="1200" u="none">
+                  <a:defRPr b="0" i="0" strike="noStrike" sz="900" u="none">
                     <a:solidFill>
-                      <a:srgbClr val="000000"/>
+                      <a:srgbClr val="1A2A38"/>
                     </a:solidFill>
                     <a:latin typeface="Arial"/>
                   </a:defRPr>
@@ -1060,7 +1276,7 @@
               </a:p>
             </c:txPr>
             <c:showLegendKey val="0"/>
-            <c:showVal val="0"/>
+            <c:showVal val="1"/>
             <c:showCatName val="0"/>
             <c:showSerName val="0"/>
             <c:showPercent val="0"/>
@@ -1106,15 +1322,15 @@
           </c:val>
         </c:ser>
         <c:dLbls>
-          <c:numFmt formatCode="#,##0" sourceLinked="0"/>
+          <c:numFmt formatCode="0.00" sourceLinked="0"/>
           <c:txPr>
             <a:bodyPr/>
             <a:lstStyle/>
             <a:p>
               <a:pPr>
-                <a:defRPr b="0" i="0" strike="noStrike" sz="1200" u="none">
+                <a:defRPr b="0" i="0" strike="noStrike" sz="900" u="none">
                   <a:solidFill>
-                    <a:srgbClr val="000000"/>
+                    <a:srgbClr val="1A2A38"/>
                   </a:solidFill>
                   <a:latin typeface="Arial"/>
                 </a:defRPr>
@@ -1122,7 +1338,7 @@
             </a:p>
           </c:txPr>
           <c:showLegendKey val="0"/>
-          <c:showVal val="0"/>
+          <c:showVal val="1"/>
           <c:showCatName val="0"/>
           <c:showSerName val="0"/>
           <c:showPercent val="0"/>
@@ -5473,7 +5689,7 @@
         </p:nvGraphicFramePr>
         <p:xfrm>
           <a:off x="548640" y="1783080"/>
-          <a:ext cx="6492240" cy="4023360"/>
+          <a:ext cx="6492240" cy="3794760"/>
         </p:xfrm>
         <a:graphic xmlns:a="http://schemas.openxmlformats.org/drawingml/2006/main">
           <a:graphicData uri="http://schemas.openxmlformats.org/drawingml/2006/chart">
@@ -5483,7 +5699,46 @@
       </p:graphicFrame>
       <p:sp>
         <p:nvSpPr>
-          <p:cNvPr id="5" name="Shape 2"/>
+          <p:cNvPr id="5" name="Text 2"/>
+          <p:cNvSpPr/>
+          <p:nvPr/>
+        </p:nvSpPr>
+        <p:spPr>
+          <a:xfrm>
+            <a:off x="548640" y="5623560"/>
+            <a:ext cx="6492240" cy="365760"/>
+          </a:xfrm>
+          <a:prstGeom prst="rect">
+            <a:avLst/>
+          </a:prstGeom>
+          <a:noFill/>
+          <a:ln/>
+        </p:spPr>
+        <p:txBody>
+          <a:bodyPr wrap="square" rtlCol="0" anchor="ctr"/>
+          <a:lstStyle/>
+          <a:p>
+            <a:pPr indent="0" marL="0">
+              <a:buNone/>
+            </a:pPr>
+            <a:r>
+              <a:rPr lang="en-US" sz="1050" i="1" dirty="0">
+                <a:solidFill>
+                  <a:srgbClr val="6B7C8C"/>
+                </a:solidFill>
+                <a:latin typeface="Calibri" pitchFamily="34" charset="0"/>
+                <a:ea typeface="Calibri" pitchFamily="34" charset="-122"/>
+                <a:cs typeface="Calibri" pitchFamily="34" charset="-120"/>
+              </a:rPr>
+              <a:t>OMDA (lighter segment) is a different kind of reach: 380 micro-distributors, not a refrigerated fleet calling on shops weekly.</a:t>
+            </a:r>
+            <a:endParaRPr lang="en-US" sz="1050" dirty="0"/>
+          </a:p>
+        </p:txBody>
+      </p:sp>
+      <p:sp>
+        <p:nvSpPr>
+          <p:cNvPr id="6" name="Shape 3"/>
           <p:cNvSpPr/>
           <p:nvPr/>
         </p:nvSpPr>
@@ -5510,7 +5765,7 @@
       </p:sp>
       <p:sp>
         <p:nvSpPr>
-          <p:cNvPr id="6" name="Text 3"/>
+          <p:cNvPr id="7" name="Text 4"/>
           <p:cNvSpPr/>
           <p:nvPr/>
         </p:nvSpPr>
@@ -5549,7 +5804,7 @@
       </p:sp>
       <p:sp>
         <p:nvSpPr>
-          <p:cNvPr id="7" name="Text 4"/>
+          <p:cNvPr id="8" name="Text 5"/>
           <p:cNvSpPr/>
           <p:nvPr/>
         </p:nvSpPr>
@@ -5655,7 +5910,7 @@
       </p:sp>
       <p:sp>
         <p:nvSpPr>
-          <p:cNvPr id="8" name="Text 5"/>
+          <p:cNvPr id="9" name="Text 6"/>
           <p:cNvSpPr/>
           <p:nvPr/>
         </p:nvSpPr>
@@ -5694,7 +5949,7 @@
       </p:sp>
       <p:sp>
         <p:nvSpPr>
-          <p:cNvPr id="9" name="Text 6"/>
+          <p:cNvPr id="10" name="Text 7"/>
           <p:cNvSpPr/>
           <p:nvPr/>
         </p:nvSpPr>
@@ -8522,14 +8777,39 @@
       </p:graphicFrame>
       <p:sp>
         <p:nvSpPr>
-          <p:cNvPr id="6" name="Text 3"/>
-          <p:cNvSpPr/>
-          <p:nvPr/>
-        </p:nvSpPr>
-        <p:spPr>
-          <a:xfrm>
-            <a:off x="548640" y="5806440"/>
-            <a:ext cx="5486400" cy="457200"/>
+          <p:cNvPr id="6" name="Shape 3"/>
+          <p:cNvSpPr/>
+          <p:nvPr/>
+        </p:nvSpPr>
+        <p:spPr>
+          <a:xfrm>
+            <a:off x="548640" y="5779008"/>
+            <a:ext cx="5486400" cy="475488"/>
+          </a:xfrm>
+          <a:prstGeom prst="rect">
+            <a:avLst/>
+          </a:prstGeom>
+          <a:solidFill>
+            <a:srgbClr val="FDEEEA"/>
+          </a:solidFill>
+          <a:ln w="12700">
+            <a:solidFill>
+              <a:srgbClr val="E1604D"/>
+            </a:solidFill>
+            <a:prstDash val="solid"/>
+          </a:ln>
+        </p:spPr>
+      </p:sp>
+      <p:sp>
+        <p:nvSpPr>
+          <p:cNvPr id="7" name="Text 4"/>
+          <p:cNvSpPr/>
+          <p:nvPr/>
+        </p:nvSpPr>
+        <p:spPr>
+          <a:xfrm>
+            <a:off x="685800" y="5779008"/>
+            <a:ext cx="5257800" cy="475488"/>
           </a:xfrm>
           <a:prstGeom prst="rect">
             <a:avLst/>
@@ -8545,15 +8825,29 @@
               <a:buNone/>
             </a:pPr>
             <a:r>
+              <a:rPr lang="en-US" sz="1150" b="1" dirty="0">
+                <a:solidFill>
+                  <a:srgbClr val="E1604D"/>
+                </a:solidFill>
+                <a:latin typeface="Calibri" pitchFamily="34" charset="0"/>
+                <a:ea typeface="Calibri" pitchFamily="34" charset="-122"/>
+                <a:cs typeface="Calibri" pitchFamily="34" charset="-120"/>
+              </a:rPr>
+              <a:t>Gap = 0.53 of a point (1-5 scale).  </a:t>
+            </a:r>
+            <a:pPr indent="0" marL="0">
+              <a:buNone/>
+            </a:pPr>
+            <a:r>
               <a:rPr lang="en-US" sz="1150" i="1" dirty="0">
                 <a:solidFill>
-                  <a:srgbClr val="6B7C8C"/>
-                </a:solidFill>
-                <a:latin typeface="Calibri" pitchFamily="34" charset="0"/>
-                <a:ea typeface="Calibri" pitchFamily="34" charset="-122"/>
-                <a:cs typeface="Calibri" pitchFamily="34" charset="-120"/>
-              </a:rPr>
-              <a:t>Gap = 0.53. Modest at the consumer level, but the urban sample understates it.</a:t>
+                  <a:srgbClr val="1A2A38"/>
+                </a:solidFill>
+                <a:latin typeface="Calibri" pitchFamily="34" charset="0"/>
+                <a:ea typeface="Calibri" pitchFamily="34" charset="-122"/>
+                <a:cs typeface="Calibri" pitchFamily="34" charset="-120"/>
+              </a:rPr>
+              <a:t>Modest at the consumer level, and the urban sample understates it.</a:t>
             </a:r>
             <a:endParaRPr lang="en-US" sz="1150" dirty="0"/>
           </a:p>
@@ -8561,7 +8855,7 @@
       </p:sp>
       <p:sp>
         <p:nvSpPr>
-          <p:cNvPr id="7" name="Text 4"/>
+          <p:cNvPr id="8" name="Text 5"/>
           <p:cNvSpPr/>
           <p:nvPr/>
         </p:nvSpPr>
@@ -8600,7 +8894,7 @@
       </p:sp>
       <p:sp>
         <p:nvSpPr>
-          <p:cNvPr id="8" name="Shape 5"/>
+          <p:cNvPr id="9" name="Shape 6"/>
           <p:cNvSpPr/>
           <p:nvPr/>
         </p:nvSpPr>
@@ -8632,7 +8926,7 @@
       </p:sp>
       <p:sp>
         <p:nvSpPr>
-          <p:cNvPr id="9" name="Shape 6"/>
+          <p:cNvPr id="10" name="Shape 7"/>
           <p:cNvSpPr/>
           <p:nvPr/>
         </p:nvSpPr>
@@ -8652,7 +8946,7 @@
       </p:sp>
       <p:sp>
         <p:nvSpPr>
-          <p:cNvPr id="10" name="Text 7"/>
+          <p:cNvPr id="11" name="Text 8"/>
           <p:cNvSpPr/>
           <p:nvPr/>
         </p:nvSpPr>
@@ -8691,7 +8985,7 @@
       </p:sp>
       <p:sp>
         <p:nvSpPr>
-          <p:cNvPr id="11" name="Text 8"/>
+          <p:cNvPr id="12" name="Text 9"/>
           <p:cNvSpPr/>
           <p:nvPr/>
         </p:nvSpPr>
@@ -8730,7 +9024,7 @@
       </p:sp>
       <p:sp>
         <p:nvSpPr>
-          <p:cNvPr id="12" name="Shape 9"/>
+          <p:cNvPr id="13" name="Shape 10"/>
           <p:cNvSpPr/>
           <p:nvPr/>
         </p:nvSpPr>
@@ -8762,7 +9056,7 @@
       </p:sp>
       <p:sp>
         <p:nvSpPr>
-          <p:cNvPr id="13" name="Shape 10"/>
+          <p:cNvPr id="14" name="Shape 11"/>
           <p:cNvSpPr/>
           <p:nvPr/>
         </p:nvSpPr>
@@ -8782,7 +9076,7 @@
       </p:sp>
       <p:sp>
         <p:nvSpPr>
-          <p:cNvPr id="14" name="Text 11"/>
+          <p:cNvPr id="15" name="Text 12"/>
           <p:cNvSpPr/>
           <p:nvPr/>
         </p:nvSpPr>
@@ -8821,7 +9115,7 @@
       </p:sp>
       <p:sp>
         <p:nvSpPr>
-          <p:cNvPr id="15" name="Text 12"/>
+          <p:cNvPr id="16" name="Text 13"/>
           <p:cNvSpPr/>
           <p:nvPr/>
         </p:nvSpPr>
@@ -8860,7 +9154,7 @@
       </p:sp>
       <p:sp>
         <p:nvSpPr>
-          <p:cNvPr id="16" name="Shape 13"/>
+          <p:cNvPr id="17" name="Shape 14"/>
           <p:cNvSpPr/>
           <p:nvPr/>
         </p:nvSpPr>
@@ -8892,7 +9186,7 @@
       </p:sp>
       <p:sp>
         <p:nvSpPr>
-          <p:cNvPr id="17" name="Shape 14"/>
+          <p:cNvPr id="18" name="Shape 15"/>
           <p:cNvSpPr/>
           <p:nvPr/>
         </p:nvSpPr>
@@ -8912,7 +9206,7 @@
       </p:sp>
       <p:sp>
         <p:nvSpPr>
-          <p:cNvPr id="18" name="Text 15"/>
+          <p:cNvPr id="19" name="Text 16"/>
           <p:cNvSpPr/>
           <p:nvPr/>
         </p:nvSpPr>
@@ -8951,7 +9245,7 @@
       </p:sp>
       <p:sp>
         <p:nvSpPr>
-          <p:cNvPr id="19" name="Text 16"/>
+          <p:cNvPr id="20" name="Text 17"/>
           <p:cNvSpPr/>
           <p:nvPr/>
         </p:nvSpPr>
@@ -8990,7 +9284,7 @@
       </p:sp>
       <p:sp>
         <p:nvSpPr>
-          <p:cNvPr id="20" name="Text 17"/>
+          <p:cNvPr id="21" name="Text 18"/>
           <p:cNvSpPr/>
           <p:nvPr/>
         </p:nvSpPr>
@@ -9029,7 +9323,7 @@
       </p:sp>
       <p:sp>
         <p:nvSpPr>
-          <p:cNvPr id="21" name="Text 18"/>
+          <p:cNvPr id="22" name="Text 19"/>
           <p:cNvSpPr/>
           <p:nvPr/>
         </p:nvSpPr>
@@ -9223,7 +9517,7 @@
         </p:nvGraphicFramePr>
         <p:xfrm>
           <a:off x="548640" y="2011680"/>
-          <a:ext cx="5852160" cy="3657600"/>
+          <a:ext cx="5852160" cy="3474720"/>
         </p:xfrm>
         <a:graphic xmlns:a="http://schemas.openxmlformats.org/drawingml/2006/main">
           <a:graphicData uri="http://schemas.openxmlformats.org/drawingml/2006/chart">
@@ -9233,14 +9527,39 @@
       </p:graphicFrame>
       <p:sp>
         <p:nvSpPr>
-          <p:cNvPr id="6" name="Text 3"/>
-          <p:cNvSpPr/>
-          <p:nvPr/>
-        </p:nvSpPr>
-        <p:spPr>
-          <a:xfrm>
-            <a:off x="548640" y="5760720"/>
-            <a:ext cx="5852160" cy="457200"/>
+          <p:cNvPr id="6" name="Shape 3"/>
+          <p:cNvSpPr/>
+          <p:nvPr/>
+        </p:nvSpPr>
+        <p:spPr>
+          <a:xfrm>
+            <a:off x="548640" y="5532120"/>
+            <a:ext cx="1874520" cy="566928"/>
+          </a:xfrm>
+          <a:prstGeom prst="rect">
+            <a:avLst/>
+          </a:prstGeom>
+          <a:solidFill>
+            <a:srgbClr val="F4F7FA"/>
+          </a:solidFill>
+          <a:ln w="12700">
+            <a:solidFill>
+              <a:srgbClr val="E3E9EF"/>
+            </a:solidFill>
+            <a:prstDash val="solid"/>
+          </a:ln>
+        </p:spPr>
+      </p:sp>
+      <p:sp>
+        <p:nvSpPr>
+          <p:cNvPr id="7" name="Text 4"/>
+          <p:cNvSpPr/>
+          <p:nvPr/>
+        </p:nvSpPr>
+        <p:spPr>
+          <a:xfrm>
+            <a:off x="621792" y="5532120"/>
+            <a:ext cx="1783080" cy="566928"/>
           </a:xfrm>
           <a:prstGeom prst="rect">
             <a:avLst/>
@@ -9256,7 +9575,7 @@
               <a:buNone/>
             </a:pPr>
             <a:r>
-              <a:rPr lang="en-US" sz="1100" i="1" dirty="0">
+              <a:rPr lang="en-US" sz="1050" dirty="0">
                 <a:solidFill>
                   <a:srgbClr val="6B7C8C"/>
                 </a:solidFill>
@@ -9264,15 +9583,266 @@
                 <a:ea typeface="Calibri" pitchFamily="34" charset="-122"/>
                 <a:cs typeface="Calibri" pitchFamily="34" charset="-120"/>
               </a:rPr>
-              <a:t>City-to-town dip in the survey; only 2 rural respondents, so H4 leans on the interviews.</a:t>
-            </a:r>
-            <a:endParaRPr lang="en-US" sz="1100" dirty="0"/>
-          </a:p>
-        </p:txBody>
-      </p:sp>
-      <p:sp>
-        <p:nvSpPr>
-          <p:cNvPr id="7" name="Shape 4"/>
+              <a:t>Major city: </a:t>
+            </a:r>
+            <a:pPr indent="0" marL="0">
+              <a:buNone/>
+            </a:pPr>
+            <a:r>
+              <a:rPr lang="en-US" sz="1050" b="1" dirty="0">
+                <a:solidFill>
+                  <a:srgbClr val="0F2C4C"/>
+                </a:solidFill>
+                <a:latin typeface="Calibri" pitchFamily="34" charset="0"/>
+                <a:ea typeface="Calibri" pitchFamily="34" charset="-122"/>
+                <a:cs typeface="Calibri" pitchFamily="34" charset="-120"/>
+              </a:rPr>
+              <a:t>gap 0.50</a:t>
+            </a:r>
+            <a:pPr indent="0" marL="0">
+              <a:buNone/>
+            </a:pPr>
+            <a:r>
+              <a:rPr lang="en-US" sz="850" dirty="0">
+                <a:solidFill>
+                  <a:srgbClr val="6B7C8C"/>
+                </a:solidFill>
+                <a:latin typeface="Calibri" pitchFamily="34" charset="0"/>
+                <a:ea typeface="Calibri" pitchFamily="34" charset="-122"/>
+                <a:cs typeface="Calibri" pitchFamily="34" charset="-120"/>
+              </a:rPr>
+              <a:t>  n=23</a:t>
+            </a:r>
+            <a:endParaRPr lang="en-US" sz="1050" dirty="0"/>
+          </a:p>
+        </p:txBody>
+      </p:sp>
+      <p:sp>
+        <p:nvSpPr>
+          <p:cNvPr id="8" name="Shape 5"/>
+          <p:cNvSpPr/>
+          <p:nvPr/>
+        </p:nvSpPr>
+        <p:spPr>
+          <a:xfrm>
+            <a:off x="2532888" y="5532120"/>
+            <a:ext cx="1874520" cy="566928"/>
+          </a:xfrm>
+          <a:prstGeom prst="rect">
+            <a:avLst/>
+          </a:prstGeom>
+          <a:solidFill>
+            <a:srgbClr val="FDEEEA"/>
+          </a:solidFill>
+          <a:ln w="12700">
+            <a:solidFill>
+              <a:srgbClr val="E1604D"/>
+            </a:solidFill>
+            <a:prstDash val="solid"/>
+          </a:ln>
+        </p:spPr>
+      </p:sp>
+      <p:sp>
+        <p:nvSpPr>
+          <p:cNvPr id="9" name="Text 6"/>
+          <p:cNvSpPr/>
+          <p:nvPr/>
+        </p:nvSpPr>
+        <p:spPr>
+          <a:xfrm>
+            <a:off x="2606040" y="5532120"/>
+            <a:ext cx="1783080" cy="566928"/>
+          </a:xfrm>
+          <a:prstGeom prst="rect">
+            <a:avLst/>
+          </a:prstGeom>
+          <a:noFill/>
+          <a:ln/>
+        </p:spPr>
+        <p:txBody>
+          <a:bodyPr wrap="square" rtlCol="0" anchor="ctr"/>
+          <a:lstStyle/>
+          <a:p>
+            <a:pPr indent="0" marL="0">
+              <a:buNone/>
+            </a:pPr>
+            <a:r>
+              <a:rPr lang="en-US" sz="1050" dirty="0">
+                <a:solidFill>
+                  <a:srgbClr val="6B7C8C"/>
+                </a:solidFill>
+                <a:latin typeface="Calibri" pitchFamily="34" charset="0"/>
+                <a:ea typeface="Calibri" pitchFamily="34" charset="-122"/>
+                <a:cs typeface="Calibri" pitchFamily="34" charset="-120"/>
+              </a:rPr>
+              <a:t>Town: </a:t>
+            </a:r>
+            <a:pPr indent="0" marL="0">
+              <a:buNone/>
+            </a:pPr>
+            <a:r>
+              <a:rPr lang="en-US" sz="1050" b="1" dirty="0">
+                <a:solidFill>
+                  <a:srgbClr val="E1604D"/>
+                </a:solidFill>
+                <a:latin typeface="Calibri" pitchFamily="34" charset="0"/>
+                <a:ea typeface="Calibri" pitchFamily="34" charset="-122"/>
+                <a:cs typeface="Calibri" pitchFamily="34" charset="-120"/>
+              </a:rPr>
+              <a:t>gap 0.70</a:t>
+            </a:r>
+            <a:pPr indent="0" marL="0">
+              <a:buNone/>
+            </a:pPr>
+            <a:r>
+              <a:rPr lang="en-US" sz="850" dirty="0">
+                <a:solidFill>
+                  <a:srgbClr val="6B7C8C"/>
+                </a:solidFill>
+                <a:latin typeface="Calibri" pitchFamily="34" charset="0"/>
+                <a:ea typeface="Calibri" pitchFamily="34" charset="-122"/>
+                <a:cs typeface="Calibri" pitchFamily="34" charset="-120"/>
+              </a:rPr>
+              <a:t>  n=10</a:t>
+            </a:r>
+            <a:endParaRPr lang="en-US" sz="1050" dirty="0"/>
+          </a:p>
+        </p:txBody>
+      </p:sp>
+      <p:sp>
+        <p:nvSpPr>
+          <p:cNvPr id="10" name="Shape 7"/>
+          <p:cNvSpPr/>
+          <p:nvPr/>
+        </p:nvSpPr>
+        <p:spPr>
+          <a:xfrm>
+            <a:off x="4517136" y="5532120"/>
+            <a:ext cx="1874520" cy="566928"/>
+          </a:xfrm>
+          <a:prstGeom prst="rect">
+            <a:avLst/>
+          </a:prstGeom>
+          <a:solidFill>
+            <a:srgbClr val="F4F7FA"/>
+          </a:solidFill>
+          <a:ln w="12700">
+            <a:solidFill>
+              <a:srgbClr val="E3E9EF"/>
+            </a:solidFill>
+            <a:prstDash val="solid"/>
+          </a:ln>
+        </p:spPr>
+      </p:sp>
+      <p:sp>
+        <p:nvSpPr>
+          <p:cNvPr id="11" name="Text 8"/>
+          <p:cNvSpPr/>
+          <p:nvPr/>
+        </p:nvSpPr>
+        <p:spPr>
+          <a:xfrm>
+            <a:off x="4590288" y="5532120"/>
+            <a:ext cx="1783080" cy="566928"/>
+          </a:xfrm>
+          <a:prstGeom prst="rect">
+            <a:avLst/>
+          </a:prstGeom>
+          <a:noFill/>
+          <a:ln/>
+        </p:spPr>
+        <p:txBody>
+          <a:bodyPr wrap="square" rtlCol="0" anchor="ctr"/>
+          <a:lstStyle/>
+          <a:p>
+            <a:pPr indent="0" marL="0">
+              <a:buNone/>
+            </a:pPr>
+            <a:r>
+              <a:rPr lang="en-US" sz="1050" dirty="0">
+                <a:solidFill>
+                  <a:srgbClr val="6B7C8C"/>
+                </a:solidFill>
+                <a:latin typeface="Calibri" pitchFamily="34" charset="0"/>
+                <a:ea typeface="Calibri" pitchFamily="34" charset="-122"/>
+                <a:cs typeface="Calibri" pitchFamily="34" charset="-120"/>
+              </a:rPr>
+              <a:t>Village: </a:t>
+            </a:r>
+            <a:pPr indent="0" marL="0">
+              <a:buNone/>
+            </a:pPr>
+            <a:r>
+              <a:rPr lang="en-US" sz="1050" b="1" dirty="0">
+                <a:solidFill>
+                  <a:srgbClr val="0F2C4C"/>
+                </a:solidFill>
+                <a:latin typeface="Calibri" pitchFamily="34" charset="0"/>
+                <a:ea typeface="Calibri" pitchFamily="34" charset="-122"/>
+                <a:cs typeface="Calibri" pitchFamily="34" charset="-120"/>
+              </a:rPr>
+              <a:t>gap 0.00</a:t>
+            </a:r>
+            <a:pPr indent="0" marL="0">
+              <a:buNone/>
+            </a:pPr>
+            <a:r>
+              <a:rPr lang="en-US" sz="850" dirty="0">
+                <a:solidFill>
+                  <a:srgbClr val="6B7C8C"/>
+                </a:solidFill>
+                <a:latin typeface="Calibri" pitchFamily="34" charset="0"/>
+                <a:ea typeface="Calibri" pitchFamily="34" charset="-122"/>
+                <a:cs typeface="Calibri" pitchFamily="34" charset="-120"/>
+              </a:rPr>
+              <a:t>  n=2</a:t>
+            </a:r>
+            <a:endParaRPr lang="en-US" sz="1050" dirty="0"/>
+          </a:p>
+        </p:txBody>
+      </p:sp>
+      <p:sp>
+        <p:nvSpPr>
+          <p:cNvPr id="12" name="Text 9"/>
+          <p:cNvSpPr/>
+          <p:nvPr/>
+        </p:nvSpPr>
+        <p:spPr>
+          <a:xfrm>
+            <a:off x="548640" y="6144768"/>
+            <a:ext cx="5852160" cy="320040"/>
+          </a:xfrm>
+          <a:prstGeom prst="rect">
+            <a:avLst/>
+          </a:prstGeom>
+          <a:noFill/>
+          <a:ln/>
+        </p:spPr>
+        <p:txBody>
+          <a:bodyPr wrap="square" rtlCol="0" anchor="ctr"/>
+          <a:lstStyle/>
+          <a:p>
+            <a:pPr indent="0" marL="0">
+              <a:buNone/>
+            </a:pPr>
+            <a:r>
+              <a:rPr lang="en-US" sz="1000" i="1" dirty="0">
+                <a:solidFill>
+                  <a:srgbClr val="6B7C8C"/>
+                </a:solidFill>
+                <a:latin typeface="Calibri" pitchFamily="34" charset="0"/>
+                <a:ea typeface="Calibri" pitchFamily="34" charset="-122"/>
+                <a:cs typeface="Calibri" pitchFamily="34" charset="-120"/>
+              </a:rPr>
+              <a:t>Gap widens city-to-town; only 2 rural respondents, so the village cell leans on the interviews.</a:t>
+            </a:r>
+            <a:endParaRPr lang="en-US" sz="1000" dirty="0"/>
+          </a:p>
+        </p:txBody>
+      </p:sp>
+      <p:sp>
+        <p:nvSpPr>
+          <p:cNvPr id="13" name="Shape 10"/>
           <p:cNvSpPr/>
           <p:nvPr/>
         </p:nvSpPr>
@@ -9304,7 +9874,7 @@
       </p:sp>
       <p:sp>
         <p:nvSpPr>
-          <p:cNvPr id="8" name="Shape 5"/>
+          <p:cNvPr id="14" name="Shape 11"/>
           <p:cNvSpPr/>
           <p:nvPr/>
         </p:nvSpPr>
@@ -9324,7 +9894,7 @@
       </p:sp>
       <p:sp>
         <p:nvSpPr>
-          <p:cNvPr id="9" name="Shape 6"/>
+          <p:cNvPr id="15" name="Shape 12"/>
           <p:cNvSpPr/>
           <p:nvPr/>
         </p:nvSpPr>
@@ -9344,7 +9914,7 @@
       </p:sp>
       <p:sp>
         <p:nvSpPr>
-          <p:cNvPr id="10" name="Text 7"/>
+          <p:cNvPr id="16" name="Text 13"/>
           <p:cNvSpPr/>
           <p:nvPr/>
         </p:nvSpPr>
@@ -9383,7 +9953,7 @@
       </p:sp>
       <p:sp>
         <p:nvSpPr>
-          <p:cNvPr id="11" name="Text 8"/>
+          <p:cNvPr id="17" name="Text 14"/>
           <p:cNvSpPr/>
           <p:nvPr/>
         </p:nvSpPr>
@@ -9422,7 +9992,7 @@
       </p:sp>
       <p:sp>
         <p:nvSpPr>
-          <p:cNvPr id="12" name="Text 9"/>
+          <p:cNvPr id="18" name="Text 15"/>
           <p:cNvSpPr/>
           <p:nvPr/>
         </p:nvSpPr>
@@ -9461,7 +10031,7 @@
       </p:sp>
       <p:sp>
         <p:nvSpPr>
-          <p:cNvPr id="13" name="Shape 10"/>
+          <p:cNvPr id="19" name="Shape 16"/>
           <p:cNvSpPr/>
           <p:nvPr/>
         </p:nvSpPr>
@@ -9493,7 +10063,7 @@
       </p:sp>
       <p:sp>
         <p:nvSpPr>
-          <p:cNvPr id="14" name="Shape 11"/>
+          <p:cNvPr id="20" name="Shape 17"/>
           <p:cNvSpPr/>
           <p:nvPr/>
         </p:nvSpPr>
@@ -9513,7 +10083,7 @@
       </p:sp>
       <p:sp>
         <p:nvSpPr>
-          <p:cNvPr id="15" name="Shape 12"/>
+          <p:cNvPr id="21" name="Shape 18"/>
           <p:cNvSpPr/>
           <p:nvPr/>
         </p:nvSpPr>
@@ -9533,7 +10103,7 @@
       </p:sp>
       <p:sp>
         <p:nvSpPr>
-          <p:cNvPr id="16" name="Text 13"/>
+          <p:cNvPr id="22" name="Text 19"/>
           <p:cNvSpPr/>
           <p:nvPr/>
         </p:nvSpPr>
@@ -9572,7 +10142,7 @@
       </p:sp>
       <p:sp>
         <p:nvSpPr>
-          <p:cNvPr id="17" name="Text 14"/>
+          <p:cNvPr id="23" name="Text 20"/>
           <p:cNvSpPr/>
           <p:nvPr/>
         </p:nvSpPr>
@@ -9611,7 +10181,7 @@
       </p:sp>
       <p:sp>
         <p:nvSpPr>
-          <p:cNvPr id="18" name="Text 15"/>
+          <p:cNvPr id="24" name="Text 21"/>
           <p:cNvSpPr/>
           <p:nvPr/>
         </p:nvSpPr>
@@ -9650,7 +10220,7 @@
       </p:sp>
       <p:sp>
         <p:nvSpPr>
-          <p:cNvPr id="19" name="Shape 16"/>
+          <p:cNvPr id="25" name="Shape 22"/>
           <p:cNvSpPr/>
           <p:nvPr/>
         </p:nvSpPr>
@@ -9682,7 +10252,7 @@
       </p:sp>
       <p:sp>
         <p:nvSpPr>
-          <p:cNvPr id="20" name="Shape 17"/>
+          <p:cNvPr id="26" name="Shape 23"/>
           <p:cNvSpPr/>
           <p:nvPr/>
         </p:nvSpPr>
@@ -9702,7 +10272,7 @@
       </p:sp>
       <p:sp>
         <p:nvSpPr>
-          <p:cNvPr id="21" name="Shape 18"/>
+          <p:cNvPr id="27" name="Shape 24"/>
           <p:cNvSpPr/>
           <p:nvPr/>
         </p:nvSpPr>
@@ -9722,7 +10292,7 @@
       </p:sp>
       <p:sp>
         <p:nvSpPr>
-          <p:cNvPr id="22" name="Text 19"/>
+          <p:cNvPr id="28" name="Text 25"/>
           <p:cNvSpPr/>
           <p:nvPr/>
         </p:nvSpPr>
@@ -9761,7 +10331,7 @@
       </p:sp>
       <p:sp>
         <p:nvSpPr>
-          <p:cNvPr id="23" name="Text 20"/>
+          <p:cNvPr id="29" name="Text 26"/>
           <p:cNvSpPr/>
           <p:nvPr/>
         </p:nvSpPr>
@@ -9800,7 +10370,7 @@
       </p:sp>
       <p:sp>
         <p:nvSpPr>
-          <p:cNvPr id="24" name="Text 21"/>
+          <p:cNvPr id="30" name="Text 27"/>
           <p:cNvSpPr/>
           <p:nvPr/>
         </p:nvSpPr>
@@ -9839,7 +10409,7 @@
       </p:sp>
       <p:sp>
         <p:nvSpPr>
-          <p:cNvPr id="25" name="Shape 22"/>
+          <p:cNvPr id="31" name="Shape 28"/>
           <p:cNvSpPr/>
           <p:nvPr/>
         </p:nvSpPr>
@@ -9871,7 +10441,7 @@
       </p:sp>
       <p:sp>
         <p:nvSpPr>
-          <p:cNvPr id="26" name="Shape 23"/>
+          <p:cNvPr id="32" name="Shape 29"/>
           <p:cNvSpPr/>
           <p:nvPr/>
         </p:nvSpPr>
@@ -9891,7 +10461,7 @@
       </p:sp>
       <p:sp>
         <p:nvSpPr>
-          <p:cNvPr id="27" name="Shape 24"/>
+          <p:cNvPr id="33" name="Shape 30"/>
           <p:cNvSpPr/>
           <p:nvPr/>
         </p:nvSpPr>
@@ -9911,7 +10481,7 @@
       </p:sp>
       <p:sp>
         <p:nvSpPr>
-          <p:cNvPr id="28" name="Text 25"/>
+          <p:cNvPr id="34" name="Text 31"/>
           <p:cNvSpPr/>
           <p:nvPr/>
         </p:nvSpPr>
@@ -9950,7 +10520,7 @@
       </p:sp>
       <p:sp>
         <p:nvSpPr>
-          <p:cNvPr id="29" name="Text 26"/>
+          <p:cNvPr id="35" name="Text 32"/>
           <p:cNvSpPr/>
           <p:nvPr/>
         </p:nvSpPr>
@@ -9989,7 +10559,7 @@
       </p:sp>
       <p:sp>
         <p:nvSpPr>
-          <p:cNvPr id="30" name="Text 27"/>
+          <p:cNvPr id="36" name="Text 33"/>
           <p:cNvSpPr/>
           <p:nvPr/>
         </p:nvSpPr>
@@ -10028,7 +10598,7 @@
       </p:sp>
       <p:sp>
         <p:nvSpPr>
-          <p:cNvPr id="31" name="Text 28"/>
+          <p:cNvPr id="37" name="Text 34"/>
           <p:cNvSpPr/>
           <p:nvPr/>
         </p:nvSpPr>
@@ -10067,7 +10637,7 @@
       </p:sp>
       <p:sp>
         <p:nvSpPr>
-          <p:cNvPr id="32" name="Text 29"/>
+          <p:cNvPr id="38" name="Text 35"/>
           <p:cNvSpPr/>
           <p:nvPr/>
         </p:nvSpPr>

</xml_diff>

<commit_message>
slide 11: drop OMDA from gap chart entirely (stacked total visually exceeded Juhayna); clean 2-bar chart + gap bullet
Co-Authored-By: Claude Fable 5 <noreply@anthropic.com>
</commit_message>
<xml_diff>
--- a/files/Danone_Presentation_rev4.pptx
+++ b/files/Danone_Presentation_rev4.pptx
@@ -140,7 +140,7 @@
       <c:layout/>
       <c:barChart>
         <c:barDir val="col"/>
-        <c:grouping val="stacked"/>
+        <c:grouping val="clustered"/>
         <c:varyColors val="0"/>
         <c:ser>
           <c:idx val="0"/>
@@ -151,7 +151,7 @@
               <c:strCache>
                 <c:ptCount val="1"/>
                 <c:pt idx="0">
-                  <c:v>Juhayna network</c:v>
+                  <c:v>Retail outlets reached</c:v>
                 </c:pt>
               </c:strCache>
             </c:strRef>
@@ -170,9 +170,9 @@
               <a:lstStyle/>
               <a:p>
                 <a:pPr>
-                  <a:defRPr b="0" i="0" strike="noStrike" sz="1100" u="none">
+                  <a:defRPr b="0" i="0" strike="noStrike" sz="1200" u="none">
                     <a:solidFill>
-                      <a:srgbClr val="FFFFFF"/>
+                      <a:srgbClr val="1A2A38"/>
                     </a:solidFill>
                     <a:latin typeface="Arial"/>
                   </a:defRPr>
@@ -187,6 +187,28 @@
             <c:showBubbleSize val="0"/>
             <c:showLeaderLines val="0"/>
           </c:dLbls>
+          <c:dPt>
+            <c:idx val="0"/>
+            <c:invertIfNegative val="0"/>
+            <c:bubble3D val="0"/>
+            <c:spPr>
+              <a:solidFill>
+                <a:srgbClr val="E0922F"/>
+              </a:solidFill>
+              <a:effectLst/>
+            </c:spPr>
+          </c:dPt>
+          <c:dPt>
+            <c:idx val="1"/>
+            <c:invertIfNegative val="0"/>
+            <c:bubble3D val="0"/>
+            <c:spPr>
+              <a:solidFill>
+                <a:srgbClr val="1C6CAB"/>
+              </a:solidFill>
+              <a:effectLst/>
+            </c:spPr>
+          </c:dPt>
           <c:cat>
             <c:multiLvlStrRef>
               <c:f>Sheet1!$A$2:$A$3</c:f>
@@ -213,161 +235,7 @@
                   <c:v>136000</c:v>
                 </c:pt>
                 <c:pt idx="1">
-                  <c:v/>
-                </c:pt>
-              </c:numCache>
-            </c:numRef>
-          </c:val>
-        </c:ser>
-        <c:ser>
-          <c:idx val="1"/>
-          <c:order val="1"/>
-          <c:tx>
-            <c:strRef>
-              <c:f>Sheet1!$C$1</c:f>
-              <c:strCache>
-                <c:ptCount val="1"/>
-                <c:pt idx="0">
-                  <c:v>Danone core network</c:v>
-                </c:pt>
-              </c:strCache>
-            </c:strRef>
-          </c:tx>
-          <c:spPr>
-            <a:solidFill>
-              <a:srgbClr val="1C6CAB"/>
-            </a:solidFill>
-            <a:effectLst/>
-          </c:spPr>
-          <c:invertIfNegative val="0"/>
-          <c:dLbls>
-            <c:numFmt formatCode="#,##0" sourceLinked="0"/>
-            <c:txPr>
-              <a:bodyPr/>
-              <a:lstStyle/>
-              <a:p>
-                <a:pPr>
-                  <a:defRPr b="0" i="0" strike="noStrike" sz="1100" u="none">
-                    <a:solidFill>
-                      <a:srgbClr val="FFFFFF"/>
-                    </a:solidFill>
-                    <a:latin typeface="Arial"/>
-                  </a:defRPr>
-                </a:pPr>
-              </a:p>
-            </c:txPr>
-            <c:showLegendKey val="0"/>
-            <c:showVal val="1"/>
-            <c:showCatName val="0"/>
-            <c:showSerName val="0"/>
-            <c:showPercent val="0"/>
-            <c:showBubbleSize val="0"/>
-            <c:showLeaderLines val="0"/>
-          </c:dLbls>
-          <c:cat>
-            <c:multiLvlStrRef>
-              <c:f>Sheet1!$A$2:$A$3</c:f>
-              <c:multiLvlStrCache>
-                <c:ptCount val="2"/>
-                <c:lvl>
-                  <c:pt idx="0">
-                    <c:v>Juhayna</c:v>
-                  </c:pt>
-                  <c:pt idx="1">
-                    <c:v>Danone</c:v>
-                  </c:pt>
-                </c:lvl>
-              </c:multiLvlStrCache>
-            </c:multiLvlStrRef>
-          </c:cat>
-          <c:val>
-            <c:numRef>
-              <c:f>Sheet1!$C$2:$C$3</c:f>
-              <c:numCache>
-                <c:formatCode>General</c:formatCode>
-                <c:ptCount val="2"/>
-                <c:pt idx="0">
-                  <c:v/>
-                </c:pt>
-                <c:pt idx="1">
                   <c:v>100000</c:v>
-                </c:pt>
-              </c:numCache>
-            </c:numRef>
-          </c:val>
-        </c:ser>
-        <c:ser>
-          <c:idx val="2"/>
-          <c:order val="2"/>
-          <c:tx>
-            <c:strRef>
-              <c:f>Sheet1!$D$1</c:f>
-              <c:strCache>
-                <c:ptCount val="1"/>
-                <c:pt idx="0">
-                  <c:v>OMDA rural project (light-touch)</c:v>
-                </c:pt>
-              </c:strCache>
-            </c:strRef>
-          </c:tx>
-          <c:spPr>
-            <a:solidFill>
-              <a:srgbClr val="9CC3E4"/>
-            </a:solidFill>
-            <a:effectLst/>
-          </c:spPr>
-          <c:invertIfNegative val="0"/>
-          <c:dLbls>
-            <c:numFmt formatCode="#,##0" sourceLinked="0"/>
-            <c:txPr>
-              <a:bodyPr/>
-              <a:lstStyle/>
-              <a:p>
-                <a:pPr>
-                  <a:defRPr b="0" i="0" strike="noStrike" sz="1100" u="none">
-                    <a:solidFill>
-                      <a:srgbClr val="FFFFFF"/>
-                    </a:solidFill>
-                    <a:latin typeface="Arial"/>
-                  </a:defRPr>
-                </a:pPr>
-              </a:p>
-            </c:txPr>
-            <c:showLegendKey val="0"/>
-            <c:showVal val="1"/>
-            <c:showCatName val="0"/>
-            <c:showSerName val="0"/>
-            <c:showPercent val="0"/>
-            <c:showBubbleSize val="0"/>
-            <c:showLeaderLines val="0"/>
-          </c:dLbls>
-          <c:cat>
-            <c:multiLvlStrRef>
-              <c:f>Sheet1!$A$2:$A$3</c:f>
-              <c:multiLvlStrCache>
-                <c:ptCount val="2"/>
-                <c:lvl>
-                  <c:pt idx="0">
-                    <c:v>Juhayna</c:v>
-                  </c:pt>
-                  <c:pt idx="1">
-                    <c:v>Danone</c:v>
-                  </c:pt>
-                </c:lvl>
-              </c:multiLvlStrCache>
-            </c:multiLvlStrRef>
-          </c:cat>
-          <c:val>
-            <c:numRef>
-              <c:f>Sheet1!$D$2:$D$3</c:f>
-              <c:numCache>
-                <c:formatCode>General</c:formatCode>
-                <c:ptCount val="2"/>
-                <c:pt idx="0">
-                  <c:v/>
-                </c:pt>
-                <c:pt idx="1">
-                  <c:v>50000</c:v>
                 </c:pt>
               </c:numCache>
             </c:numRef>
@@ -380,9 +248,9 @@
             <a:lstStyle/>
             <a:p>
               <a:pPr>
-                <a:defRPr b="0" i="0" strike="noStrike" sz="1100" u="none">
+                <a:defRPr b="0" i="0" strike="noStrike" sz="1200" u="none">
                   <a:solidFill>
-                    <a:srgbClr val="FFFFFF"/>
+                    <a:srgbClr val="1A2A38"/>
                   </a:solidFill>
                   <a:latin typeface="Arial"/>
                 </a:defRPr>
@@ -398,7 +266,7 @@
           <c:showLeaderLines val="0"/>
         </c:dLbls>
         <c:gapWidth val="60"/>
-        <c:overlap val="100"/>
+        <c:overlap val="0"/>
         <c:axId val="2094734554"/>
         <c:axId val="2094734552"/>
         <c:axId val="2094734556"/>
@@ -502,24 +370,6 @@
         <a:effectLst/>
       </c:spPr>
     </c:plotArea>
-    <c:legend>
-      <c:legendPos val="b"/>
-      <c:overlay val="0"/>
-      <c:txPr>
-        <a:bodyPr/>
-        <a:lstStyle/>
-        <a:p>
-          <a:pPr>
-            <a:defRPr sz="1000">
-              <a:solidFill>
-                <a:srgbClr val="6B7C8C"/>
-              </a:solidFill>
-            </a:defRPr>
-          </a:pPr>
-          <a:endParaRPr lang="en-US"/>
-        </a:p>
-      </c:txPr>
-    </c:legend>
     <c:plotVisOnly val="1"/>
     <c:dispBlanksAs val="span"/>
   </c:chart>
@@ -5689,7 +5539,7 @@
         </p:nvGraphicFramePr>
         <p:xfrm>
           <a:off x="548640" y="1783080"/>
-          <a:ext cx="6492240" cy="3794760"/>
+          <a:ext cx="6492240" cy="4023360"/>
         </p:xfrm>
         <a:graphic xmlns:a="http://schemas.openxmlformats.org/drawingml/2006/main">
           <a:graphicData uri="http://schemas.openxmlformats.org/drawingml/2006/chart">
@@ -5699,46 +5549,7 @@
       </p:graphicFrame>
       <p:sp>
         <p:nvSpPr>
-          <p:cNvPr id="5" name="Text 2"/>
-          <p:cNvSpPr/>
-          <p:nvPr/>
-        </p:nvSpPr>
-        <p:spPr>
-          <a:xfrm>
-            <a:off x="548640" y="5623560"/>
-            <a:ext cx="6492240" cy="365760"/>
-          </a:xfrm>
-          <a:prstGeom prst="rect">
-            <a:avLst/>
-          </a:prstGeom>
-          <a:noFill/>
-          <a:ln/>
-        </p:spPr>
-        <p:txBody>
-          <a:bodyPr wrap="square" rtlCol="0" anchor="ctr"/>
-          <a:lstStyle/>
-          <a:p>
-            <a:pPr indent="0" marL="0">
-              <a:buNone/>
-            </a:pPr>
-            <a:r>
-              <a:rPr lang="en-US" sz="1050" i="1" dirty="0">
-                <a:solidFill>
-                  <a:srgbClr val="6B7C8C"/>
-                </a:solidFill>
-                <a:latin typeface="Calibri" pitchFamily="34" charset="0"/>
-                <a:ea typeface="Calibri" pitchFamily="34" charset="-122"/>
-                <a:cs typeface="Calibri" pitchFamily="34" charset="-120"/>
-              </a:rPr>
-              <a:t>OMDA (lighter segment) is a different kind of reach: 380 micro-distributors, not a refrigerated fleet calling on shops weekly.</a:t>
-            </a:r>
-            <a:endParaRPr lang="en-US" sz="1050" dirty="0"/>
-          </a:p>
-        </p:txBody>
-      </p:sp>
-      <p:sp>
-        <p:nvSpPr>
-          <p:cNvPr id="6" name="Shape 3"/>
+          <p:cNvPr id="5" name="Shape 2"/>
           <p:cNvSpPr/>
           <p:nvPr/>
         </p:nvSpPr>
@@ -5765,7 +5576,7 @@
       </p:sp>
       <p:sp>
         <p:nvSpPr>
-          <p:cNvPr id="7" name="Text 4"/>
+          <p:cNvPr id="6" name="Text 3"/>
           <p:cNvSpPr/>
           <p:nvPr/>
         </p:nvSpPr>
@@ -5804,7 +5615,7 @@
       </p:sp>
       <p:sp>
         <p:nvSpPr>
-          <p:cNvPr id="8" name="Text 5"/>
+          <p:cNvPr id="7" name="Text 4"/>
           <p:cNvSpPr/>
           <p:nvPr/>
         </p:nvSpPr>
@@ -5881,7 +5692,7 @@
                 <a:ea typeface="Calibri" pitchFamily="34" charset="-122"/>
                 <a:cs typeface="Calibri" pitchFamily="34" charset="-120"/>
               </a:rPr>
-              <a:t>OMDA project: ~380 micro-distributors serve ~50,000 rural retailers</a:t>
+              <a:t>Danone reaches ~36,000 fewer outlets, a ~26% gap</a:t>
             </a:r>
             <a:endParaRPr lang="en-US" sz="1300" dirty="0"/>
           </a:p>
@@ -5910,7 +5721,7 @@
       </p:sp>
       <p:sp>
         <p:nvSpPr>
-          <p:cNvPr id="9" name="Text 6"/>
+          <p:cNvPr id="8" name="Text 5"/>
           <p:cNvSpPr/>
           <p:nvPr/>
         </p:nvSpPr>
@@ -5949,7 +5760,7 @@
       </p:sp>
       <p:sp>
         <p:nvSpPr>
-          <p:cNvPr id="10" name="Text 7"/>
+          <p:cNvPr id="9" name="Text 6"/>
           <p:cNvSpPr/>
           <p:nvPr/>
         </p:nvSpPr>

</xml_diff>